<commit_message>
docs: embed high-resolution technical approach infographic into SIH PPTX Slide 3
</commit_message>
<xml_diff>
--- a/SIH_2026_PS26085_JalDrishti_Submission.pptx
+++ b/SIH_2026_PS26085_JalDrishti_Submission.pptx
@@ -4332,684 +4332,30 @@
           </a:p>
         </p:txBody>
       </p:sp>
-      <p:sp>
-        <p:nvSpPr>
-          <p:cNvPr id="4" name="Rounded Rectangle 3"/>
-          <p:cNvSpPr/>
+      <p:pic>
+        <p:nvPicPr>
+          <p:cNvPr id="4" name="Picture 3" descr="urban_flood_architecture_diagram_1788024330870.jpg"/>
+          <p:cNvPicPr>
+            <a:picLocks noChangeAspect="1"/>
+          </p:cNvPicPr>
           <p:nvPr/>
-        </p:nvSpPr>
-        <p:spPr>
-          <a:xfrm>
-            <a:off x="731520" y="1371600"/>
-            <a:ext cx="3383280" cy="4937760"/>
-          </a:xfrm>
-          <a:prstGeom prst="roundRect">
-            <a:avLst/>
-          </a:prstGeom>
-          <a:solidFill>
-            <a:srgbClr val="1E293B"/>
-          </a:solidFill>
-          <a:ln w="12700">
-            <a:solidFill>
-              <a:srgbClr val="06B6D4"/>
-            </a:solidFill>
-          </a:ln>
-        </p:spPr>
-        <p:style>
-          <a:lnRef idx="1">
-            <a:schemeClr val="accent1"/>
-          </a:lnRef>
-          <a:fillRef idx="3">
-            <a:schemeClr val="accent1"/>
-          </a:fillRef>
-          <a:effectRef idx="2">
-            <a:schemeClr val="accent1"/>
-          </a:effectRef>
-          <a:fontRef idx="minor">
-            <a:schemeClr val="lt1"/>
-          </a:fontRef>
-        </p:style>
-        <p:txBody>
-          <a:bodyPr rtlCol="0" anchor="ctr"/>
-          <a:lstStyle/>
-          <a:p>
-            <a:pPr algn="ctr"/>
-          </a:p>
-        </p:txBody>
-      </p:sp>
-      <p:sp>
-        <p:nvSpPr>
-          <p:cNvPr id="5" name="TextBox 4"/>
-          <p:cNvSpPr txBox="1"/>
-          <p:nvPr/>
-        </p:nvSpPr>
-        <p:spPr>
-          <a:xfrm>
-            <a:off x="868680" y="1508760"/>
-            <a:ext cx="3108960" cy="4663440"/>
+        </p:nvPicPr>
+        <p:blipFill>
+          <a:blip r:embed="rId2"/>
+          <a:stretch>
+            <a:fillRect/>
+          </a:stretch>
+        </p:blipFill>
+        <p:spPr>
+          <a:xfrm>
+            <a:off x="731520" y="1234440"/>
+            <a:ext cx="10728655" cy="5257800"/>
           </a:xfrm>
           <a:prstGeom prst="rect">
             <a:avLst/>
           </a:prstGeom>
-          <a:noFill/>
-        </p:spPr>
-        <p:txBody>
-          <a:bodyPr wrap="square">
-            <a:spAutoFit/>
-          </a:bodyPr>
-          <a:lstStyle/>
-          <a:p>
-            <a:pPr>
-              <a:spcAft>
-                <a:spcPts val="600"/>
-              </a:spcAft>
-              <a:defRPr sz="1100" b="1">
-                <a:solidFill>
-                  <a:srgbClr val="06B6D4"/>
-                </a:solidFill>
-              </a:defRPr>
-            </a:pPr>
-            <a:r>
-              <a:t>SYSTEM ARCHITECTURE FLOW</a:t>
-            </a:r>
-          </a:p>
-          <a:p>
-            <a:pPr>
-              <a:spcAft>
-                <a:spcPts val="500"/>
-              </a:spcAft>
-              <a:defRPr sz="850">
-                <a:solidFill>
-                  <a:srgbClr val="F8FAFC"/>
-                </a:solidFill>
-              </a:defRPr>
-            </a:pPr>
-            <a:r>
-              <a:t>1. DATA INGESTION LAYER</a:t>
-            </a:r>
-            <a:br/>
-            <a:r>
-              <a:t>• Open-Meteo Live Precipitation Feeds</a:t>
-            </a:r>
-            <a:br/>
-            <a:r>
-              <a:t>• 41 Real CSV Infrastructure Nodes</a:t>
-            </a:r>
-            <a:br/>
-            <a:r>
-              <a:t>• Arabian Sea Tide Level Logs</a:t>
-            </a:r>
-          </a:p>
-          <a:p>
-            <a:pPr>
-              <a:spcAft>
-                <a:spcPts val="500"/>
-              </a:spcAft>
-              <a:defRPr sz="850">
-                <a:solidFill>
-                  <a:srgbClr val="F8FAFC"/>
-                </a:solidFill>
-              </a:defRPr>
-            </a:pPr>
-            <a:r>
-              <a:t>2. COUPLING &amp; HYDROLOGY</a:t>
-            </a:r>
-            <a:br/>
-            <a:r>
-              <a:t>• Rational Method Runoff (C=0.88)</a:t>
-            </a:r>
-            <a:br/>
-            <a:r>
-              <a:t>• 2D DEM D8 Flow Routing Engine</a:t>
-            </a:r>
-            <a:br/>
-            <a:r>
-              <a:t>• Manning's Pipe Flow + Siltation %</a:t>
-            </a:r>
-          </a:p>
-          <a:p>
-            <a:pPr>
-              <a:spcAft>
-                <a:spcPts val="500"/>
-              </a:spcAft>
-              <a:defRPr sz="850">
-                <a:solidFill>
-                  <a:srgbClr val="F8FAFC"/>
-                </a:solidFill>
-              </a:defRPr>
-            </a:pPr>
-            <a:r>
-              <a:t>3. PREDICTION &amp; GRAPH</a:t>
-            </a:r>
-            <a:br/>
-            <a:r>
-              <a:t>• Voting Regressor (RF + GBR)</a:t>
-            </a:r>
-            <a:br/>
-            <a:r>
-              <a:t>• NetworkX DiGraph Domino Chains</a:t>
-            </a:r>
-            <a:br/>
-            <a:r>
-              <a:t>• 0-180m Forecast Timeline</a:t>
-            </a:r>
-          </a:p>
-          <a:p>
-            <a:pPr>
-              <a:spcAft>
-                <a:spcPts val="500"/>
-              </a:spcAft>
-              <a:defRPr sz="850">
-                <a:solidFill>
-                  <a:srgbClr val="F8FAFC"/>
-                </a:solidFill>
-              </a:defRPr>
-            </a:pPr>
-            <a:r>
-              <a:t>4. DECISION &amp; VISUALIZATION</a:t>
-            </a:r>
-            <a:br/>
-            <a:r>
-              <a:t>• Dijkstra Flood-Safe Navigation API</a:t>
-            </a:r>
-            <a:br/>
-            <a:r>
-              <a:t>• Deck.gl v9 3D WebGL Digital Twin</a:t>
-            </a:r>
-            <a:br/>
-            <a:r>
-              <a:t>• 360° Continuous Drone Orbit</a:t>
-            </a:r>
-          </a:p>
-        </p:txBody>
-      </p:sp>
-      <p:sp>
-        <p:nvSpPr>
-          <p:cNvPr id="6" name="Rounded Rectangle 5"/>
-          <p:cNvSpPr/>
-          <p:nvPr/>
-        </p:nvSpPr>
-        <p:spPr>
-          <a:xfrm>
-            <a:off x="4297680" y="1371600"/>
-            <a:ext cx="3931920" cy="4937760"/>
-          </a:xfrm>
-          <a:prstGeom prst="roundRect">
-            <a:avLst/>
-          </a:prstGeom>
-          <a:solidFill>
-            <a:srgbClr val="1E293B"/>
-          </a:solidFill>
-          <a:ln w="12700">
-            <a:solidFill>
-              <a:srgbClr val="F59E0B"/>
-            </a:solidFill>
-          </a:ln>
-        </p:spPr>
-        <p:style>
-          <a:lnRef idx="1">
-            <a:schemeClr val="accent1"/>
-          </a:lnRef>
-          <a:fillRef idx="3">
-            <a:schemeClr val="accent1"/>
-          </a:fillRef>
-          <a:effectRef idx="2">
-            <a:schemeClr val="accent1"/>
-          </a:effectRef>
-          <a:fontRef idx="minor">
-            <a:schemeClr val="lt1"/>
-          </a:fontRef>
-        </p:style>
-        <p:txBody>
-          <a:bodyPr rtlCol="0" anchor="ctr"/>
-          <a:lstStyle/>
-          <a:p>
-            <a:pPr algn="ctr"/>
-          </a:p>
-        </p:txBody>
-      </p:sp>
-      <p:sp>
-        <p:nvSpPr>
-          <p:cNvPr id="7" name="TextBox 6"/>
-          <p:cNvSpPr txBox="1"/>
-          <p:nvPr/>
-        </p:nvSpPr>
-        <p:spPr>
-          <a:xfrm>
-            <a:off x="4434840" y="1508760"/>
-            <a:ext cx="3657600" cy="4663440"/>
-          </a:xfrm>
-          <a:prstGeom prst="rect">
-            <a:avLst/>
-          </a:prstGeom>
-          <a:noFill/>
-        </p:spPr>
-        <p:txBody>
-          <a:bodyPr wrap="square">
-            <a:spAutoFit/>
-          </a:bodyPr>
-          <a:lstStyle/>
-          <a:p>
-            <a:pPr>
-              <a:spcAft>
-                <a:spcPts val="600"/>
-              </a:spcAft>
-              <a:defRPr sz="1100" b="1">
-                <a:solidFill>
-                  <a:srgbClr val="F59E0B"/>
-                </a:solidFill>
-              </a:defRPr>
-            </a:pPr>
-            <a:r>
-              <a:t>GOVERNING EQUATIONS &amp; LOGIC</a:t>
-            </a:r>
-          </a:p>
-          <a:p>
-            <a:pPr>
-              <a:defRPr sz="900" b="1">
-                <a:solidFill>
-                  <a:srgbClr val="38BDF8"/>
-                </a:solidFill>
-              </a:defRPr>
-            </a:pPr>
-            <a:r>
-              <a:t>▶ Rational Hydrological Runoff:</a:t>
-            </a:r>
-          </a:p>
-          <a:p>
-            <a:pPr>
-              <a:spcAft>
-                <a:spcPts val="300"/>
-              </a:spcAft>
-              <a:defRPr sz="800">
-                <a:solidFill>
-                  <a:srgbClr val="F8FAFC"/>
-                </a:solidFill>
-              </a:defRPr>
-            </a:pPr>
-            <a:r>
-              <a:t>Q_peak = 0.00278 • C • I • A</a:t>
-            </a:r>
-            <a:br/>
-            <a:r>
-              <a:t>(C=0.88 urban concrete, I=mm/h, A=catchment ha)</a:t>
-            </a:r>
-          </a:p>
-          <a:p>
-            <a:pPr>
-              <a:defRPr sz="900" b="1">
-                <a:solidFill>
-                  <a:srgbClr val="38BDF8"/>
-                </a:solidFill>
-              </a:defRPr>
-            </a:pPr>
-            <a:r>
-              <a:t>▶ Manning's Open-Channel Pipe Flow:</a:t>
-            </a:r>
-          </a:p>
-          <a:p>
-            <a:pPr>
-              <a:spcAft>
-                <a:spcPts val="300"/>
-              </a:spcAft>
-              <a:defRPr sz="800">
-                <a:solidFill>
-                  <a:srgbClr val="F8FAFC"/>
-                </a:solidFill>
-              </a:defRPr>
-            </a:pPr>
-            <a:r>
-              <a:t>Q_drain = (1/n) • A • R_h^(2/3) • S^(1/2) • (1 - Silt%/100)</a:t>
-            </a:r>
-            <a:br/>
-            <a:r>
-              <a:t>(n=0.015 concrete box conduits, S=0.002 slope)</a:t>
-            </a:r>
-          </a:p>
-          <a:p>
-            <a:pPr>
-              <a:defRPr sz="900" b="1">
-                <a:solidFill>
-                  <a:srgbClr val="38BDF8"/>
-                </a:solidFill>
-              </a:defRPr>
-            </a:pPr>
-            <a:r>
-              <a:t>▶ 2D DEM Topographic Slope Routing:</a:t>
-            </a:r>
-          </a:p>
-          <a:p>
-            <a:pPr>
-              <a:spcAft>
-                <a:spcPts val="300"/>
-              </a:spcAft>
-              <a:defRPr sz="800">
-                <a:solidFill>
-                  <a:srgbClr val="F8FAFC"/>
-                </a:solidFill>
-              </a:defRPr>
-            </a:pPr>
-            <a:r>
-              <a:t>ΔZ/ΔX Slope Gradient + D8 Flow Direction routing runoff into low-elevation saucer basins</a:t>
-            </a:r>
-          </a:p>
-          <a:p>
-            <a:pPr>
-              <a:defRPr sz="900" b="1">
-                <a:solidFill>
-                  <a:srgbClr val="38BDF8"/>
-                </a:solidFill>
-              </a:defRPr>
-            </a:pPr>
-            <a:r>
-              <a:t>▶ Tidal Backpressure Gate Lock:</a:t>
-            </a:r>
-          </a:p>
-          <a:p>
-            <a:pPr>
-              <a:spcAft>
-                <a:spcPts val="300"/>
-              </a:spcAft>
-              <a:defRPr sz="800">
-                <a:solidFill>
-                  <a:srgbClr val="F8FAFC"/>
-                </a:solidFill>
-              </a:defRPr>
-            </a:pPr>
-            <a:r>
-              <a:t>Tide &gt; 3.5m THD locks flap gates; Usable drainage capacity drops to 15% triggering backflow</a:t>
-            </a:r>
-          </a:p>
-          <a:p>
-            <a:pPr>
-              <a:defRPr sz="900" b="1">
-                <a:solidFill>
-                  <a:srgbClr val="38BDF8"/>
-                </a:solidFill>
-              </a:defRPr>
-            </a:pPr>
-            <a:r>
-              <a:t>▶ Dijkstra Dynamic Inundation Routing:</a:t>
-            </a:r>
-          </a:p>
-          <a:p>
-            <a:pPr>
-              <a:spcAft>
-                <a:spcPts val="300"/>
-              </a:spcAft>
-              <a:defRPr sz="800">
-                <a:solidFill>
-                  <a:srgbClr val="F8FAFC"/>
-                </a:solidFill>
-              </a:defRPr>
-            </a:pPr>
-            <a:r>
-              <a:t>Edge_Cost = T_base • (1 + depth/8.0) + Penalty</a:t>
-            </a:r>
-            <a:br/>
-            <a:r>
-              <a:t>(Penalty = 9999 if depth ≥ 50cm - Impassable)</a:t>
-            </a:r>
-          </a:p>
-        </p:txBody>
-      </p:sp>
-      <p:sp>
-        <p:nvSpPr>
-          <p:cNvPr id="8" name="Rounded Rectangle 7"/>
-          <p:cNvSpPr/>
-          <p:nvPr/>
-        </p:nvSpPr>
-        <p:spPr>
-          <a:xfrm>
-            <a:off x="8412480" y="1371600"/>
-            <a:ext cx="3047695" cy="4937760"/>
-          </a:xfrm>
-          <a:prstGeom prst="roundRect">
-            <a:avLst/>
-          </a:prstGeom>
-          <a:solidFill>
-            <a:srgbClr val="1E293B"/>
-          </a:solidFill>
-          <a:ln w="12700">
-            <a:solidFill>
-              <a:srgbClr val="10B981"/>
-            </a:solidFill>
-          </a:ln>
-        </p:spPr>
-        <p:style>
-          <a:lnRef idx="1">
-            <a:schemeClr val="accent1"/>
-          </a:lnRef>
-          <a:fillRef idx="3">
-            <a:schemeClr val="accent1"/>
-          </a:fillRef>
-          <a:effectRef idx="2">
-            <a:schemeClr val="accent1"/>
-          </a:effectRef>
-          <a:fontRef idx="minor">
-            <a:schemeClr val="lt1"/>
-          </a:fontRef>
-        </p:style>
-        <p:txBody>
-          <a:bodyPr rtlCol="0" anchor="ctr"/>
-          <a:lstStyle/>
-          <a:p>
-            <a:pPr algn="ctr"/>
-          </a:p>
-        </p:txBody>
-      </p:sp>
-      <p:sp>
-        <p:nvSpPr>
-          <p:cNvPr id="9" name="TextBox 8"/>
-          <p:cNvSpPr txBox="1"/>
-          <p:nvPr/>
-        </p:nvSpPr>
-        <p:spPr>
-          <a:xfrm>
-            <a:off x="8549640" y="1508760"/>
-            <a:ext cx="2773375" cy="4663440"/>
-          </a:xfrm>
-          <a:prstGeom prst="rect">
-            <a:avLst/>
-          </a:prstGeom>
-          <a:noFill/>
-        </p:spPr>
-        <p:txBody>
-          <a:bodyPr wrap="square">
-            <a:spAutoFit/>
-          </a:bodyPr>
-          <a:lstStyle/>
-          <a:p>
-            <a:pPr>
-              <a:spcAft>
-                <a:spcPts val="600"/>
-              </a:spcAft>
-              <a:defRPr sz="1100" b="1">
-                <a:solidFill>
-                  <a:srgbClr val="10B981"/>
-                </a:solidFill>
-              </a:defRPr>
-            </a:pPr>
-            <a:r>
-              <a:t>VERIFIED STACK &amp; METRICS</a:t>
-            </a:r>
-          </a:p>
-          <a:p>
-            <a:pPr>
-              <a:defRPr sz="850" b="1">
-                <a:solidFill>
-                  <a:srgbClr val="F59E0B"/>
-                </a:solidFill>
-              </a:defRPr>
-            </a:pPr>
-            <a:r>
-              <a:t>Backend Framework:</a:t>
-            </a:r>
-          </a:p>
-          <a:p>
-            <a:pPr>
-              <a:spcAft>
-                <a:spcPts val="300"/>
-              </a:spcAft>
-              <a:defRPr sz="800">
-                <a:solidFill>
-                  <a:srgbClr val="F8FAFC"/>
-                </a:solidFill>
-              </a:defRPr>
-            </a:pPr>
-            <a:r>
-              <a:t>FastAPI (Python 3.11), Uvicorn</a:t>
-            </a:r>
-          </a:p>
-          <a:p>
-            <a:pPr>
-              <a:defRPr sz="850" b="1">
-                <a:solidFill>
-                  <a:srgbClr val="F59E0B"/>
-                </a:solidFill>
-              </a:defRPr>
-            </a:pPr>
-            <a:r>
-              <a:t>Machine Learning:</a:t>
-            </a:r>
-          </a:p>
-          <a:p>
-            <a:pPr>
-              <a:spcAft>
-                <a:spcPts val="300"/>
-              </a:spcAft>
-              <a:defRPr sz="800">
-                <a:solidFill>
-                  <a:srgbClr val="F8FAFC"/>
-                </a:solidFill>
-              </a:defRPr>
-            </a:pPr>
-            <a:r>
-              <a:t>Scikit-Learn VotingRegressor (Random Forest + Gradient Boosting)</a:t>
-            </a:r>
-          </a:p>
-          <a:p>
-            <a:pPr>
-              <a:defRPr sz="850" b="1">
-                <a:solidFill>
-                  <a:srgbClr val="F59E0B"/>
-                </a:solidFill>
-              </a:defRPr>
-            </a:pPr>
-            <a:r>
-              <a:t>Graph &amp; Routing:</a:t>
-            </a:r>
-          </a:p>
-          <a:p>
-            <a:pPr>
-              <a:spcAft>
-                <a:spcPts val="300"/>
-              </a:spcAft>
-              <a:defRPr sz="800">
-                <a:solidFill>
-                  <a:srgbClr val="F8FAFC"/>
-                </a:solidFill>
-              </a:defRPr>
-            </a:pPr>
-            <a:r>
-              <a:t>NetworkX (DiGraph + Dijkstra)</a:t>
-            </a:r>
-          </a:p>
-          <a:p>
-            <a:pPr>
-              <a:defRPr sz="850" b="1">
-                <a:solidFill>
-                  <a:srgbClr val="F59E0B"/>
-                </a:solidFill>
-              </a:defRPr>
-            </a:pPr>
-            <a:r>
-              <a:t>Frontend UI:</a:t>
-            </a:r>
-          </a:p>
-          <a:p>
-            <a:pPr>
-              <a:spcAft>
-                <a:spcPts val="300"/>
-              </a:spcAft>
-              <a:defRPr sz="800">
-                <a:solidFill>
-                  <a:srgbClr val="F8FAFC"/>
-                </a:solidFill>
-              </a:defRPr>
-            </a:pPr>
-            <a:r>
-              <a:t>Next.js 14 (App Router), React 18, TypeScript, Tailwind CSS</a:t>
-            </a:r>
-          </a:p>
-          <a:p>
-            <a:pPr>
-              <a:defRPr sz="850" b="1">
-                <a:solidFill>
-                  <a:srgbClr val="F59E0B"/>
-                </a:solidFill>
-              </a:defRPr>
-            </a:pPr>
-            <a:r>
-              <a:t>3D Geospatial Engine:</a:t>
-            </a:r>
-          </a:p>
-          <a:p>
-            <a:pPr>
-              <a:spcAft>
-                <a:spcPts val="300"/>
-              </a:spcAft>
-              <a:defRPr sz="800">
-                <a:solidFill>
-                  <a:srgbClr val="F8FAFC"/>
-                </a:solidFill>
-              </a:defRPr>
-            </a:pPr>
-            <a:r>
-              <a:t>Deck.gl v9 (WebGL 2.0), MapLibre GL, Esri World Street Cartography</a:t>
-            </a:r>
-          </a:p>
-          <a:p>
-            <a:pPr>
-              <a:defRPr sz="850" b="1">
-                <a:solidFill>
-                  <a:srgbClr val="F59E0B"/>
-                </a:solidFill>
-              </a:defRPr>
-            </a:pPr>
-            <a:r>
-              <a:t>ML Training Pipeline:</a:t>
-            </a:r>
-          </a:p>
-          <a:p>
-            <a:pPr>
-              <a:spcAft>
-                <a:spcPts val="300"/>
-              </a:spcAft>
-              <a:defRPr sz="800">
-                <a:solidFill>
-                  <a:srgbClr val="F8FAFC"/>
-                </a:solidFill>
-              </a:defRPr>
-            </a:pPr>
-            <a:r>
-              <a:t>Trained on 69,720 Mumbai AWS rainfall logs + 1,940 tide records</a:t>
-            </a:r>
-            <a:br/>
-            <a:r>
-              <a:t>• R² Score: 0.9856</a:t>
-            </a:r>
-            <a:br/>
-            <a:r>
-              <a:t>• MAE: 1.36 cm | RMSE: 2.22 cm</a:t>
-            </a:r>
-            <a:br/>
-            <a:r>
-              <a:t>• Latency: &lt;45 ms per simulation</a:t>
-            </a:r>
-          </a:p>
-        </p:txBody>
-      </p:sp>
+        </p:spPr>
+      </p:pic>
     </p:spTree>
   </p:cSld>
   <p:clrMapOvr>

</xml_diff>